<commit_message>
Add service layer, profile/admin features
</commit_message>
<xml_diff>
--- a/BlogApp_Sunum.pptx
+++ b/BlogApp_Sunum.pptx
@@ -124,12 +124,20 @@
 </p:presentation>
 </file>
 
+<file path=ppt/revisionInfo.xml><?xml version="1.0" encoding="utf-8"?>
+<p1510:revInfo xmlns:a="http://schemas.openxmlformats.org/drawingml/2006/main" xmlns:r="http://schemas.openxmlformats.org/officeDocument/2006/relationships" xmlns:p1510="http://schemas.microsoft.com/office/powerpoint/2015/10/main">
+  <p1510:revLst>
+    <p1510:client id="{E3977251-63E4-499C-B16F-C1E9BB1422D3}" v="1" dt="2026-08-18T08:30:59.130"/>
+  </p1510:revLst>
+</p1510:revInfo>
+</file>
+
 <file path=ppt/changesInfos/changesInfo1.xml><?xml version="1.0" encoding="utf-8"?>
 <pc:chgInfo xmlns:a="http://schemas.openxmlformats.org/drawingml/2006/main" xmlns:r="http://schemas.openxmlformats.org/officeDocument/2006/relationships" xmlns:ac="http://schemas.microsoft.com/office/drawing/2013/main/command" xmlns:pc="http://schemas.microsoft.com/office/powerpoint/2013/main/command">
   <pc:docChgLst>
     <pc:chgData name="serra N" userId="9179cc10d8c62c08" providerId="LiveId" clId="{D30B40FB-DF3A-44D2-BDC3-B71D8C0FFE80}"/>
     <pc:docChg chg="custSel modSld">
-      <pc:chgData name="serra N" userId="9179cc10d8c62c08" providerId="LiveId" clId="{D30B40FB-DF3A-44D2-BDC3-B71D8C0FFE80}" dt="2026-08-17T06:39:58.845" v="6" actId="21"/>
+      <pc:chgData name="serra N" userId="9179cc10d8c62c08" providerId="LiveId" clId="{D30B40FB-DF3A-44D2-BDC3-B71D8C0FFE80}" dt="2026-08-18T08:31:00.183" v="9"/>
       <pc:docMkLst>
         <pc:docMk/>
       </pc:docMkLst>
@@ -139,14 +147,6 @@
           <pc:docMk/>
           <pc:sldMk cId="0" sldId="256"/>
         </pc:sldMkLst>
-        <pc:spChg chg="del">
-          <ac:chgData name="serra N" userId="9179cc10d8c62c08" providerId="LiveId" clId="{D30B40FB-DF3A-44D2-BDC3-B71D8C0FFE80}" dt="2026-08-16T20:57:20.524" v="4" actId="21"/>
-          <ac:spMkLst>
-            <pc:docMk/>
-            <pc:sldMk cId="0" sldId="256"/>
-            <ac:spMk id="5" creationId="{00000000-0000-0000-0000-000000000000}"/>
-          </ac:spMkLst>
-        </pc:spChg>
         <pc:spChg chg="mod">
           <ac:chgData name="serra N" userId="9179cc10d8c62c08" providerId="LiveId" clId="{D30B40FB-DF3A-44D2-BDC3-B71D8C0FFE80}" dt="2026-08-16T20:57:06.176" v="1" actId="20577"/>
           <ac:spMkLst>
@@ -163,14 +163,21 @@
             <ac:spMk id="13" creationId="{00000000-0000-0000-0000-000000000000}"/>
           </ac:spMkLst>
         </pc:spChg>
-        <pc:picChg chg="del">
-          <ac:chgData name="serra N" userId="9179cc10d8c62c08" providerId="LiveId" clId="{D30B40FB-DF3A-44D2-BDC3-B71D8C0FFE80}" dt="2026-08-16T20:57:17.775" v="3" actId="21"/>
-          <ac:picMkLst>
+      </pc:sldChg>
+      <pc:sldChg chg="addSp delSp modSp mod">
+        <pc:chgData name="serra N" userId="9179cc10d8c62c08" providerId="LiveId" clId="{D30B40FB-DF3A-44D2-BDC3-B71D8C0FFE80}" dt="2026-08-18T08:31:00.183" v="9"/>
+        <pc:sldMkLst>
+          <pc:docMk/>
+          <pc:sldMk cId="0" sldId="266"/>
+        </pc:sldMkLst>
+        <pc:spChg chg="add del mod">
+          <ac:chgData name="serra N" userId="9179cc10d8c62c08" providerId="LiveId" clId="{D30B40FB-DF3A-44D2-BDC3-B71D8C0FFE80}" dt="2026-08-18T08:31:00.183" v="9"/>
+          <ac:spMkLst>
             <pc:docMk/>
-            <pc:sldMk cId="0" sldId="256"/>
-            <ac:picMk id="6" creationId="{00000000-0000-0000-0000-000000000000}"/>
-          </ac:picMkLst>
-        </pc:picChg>
+            <pc:sldMk cId="0" sldId="266"/>
+            <ac:spMk id="36" creationId="{165EC8C0-D9E2-CD45-AD04-C2DFD99ECB64}"/>
+          </ac:spMkLst>
+        </pc:spChg>
       </pc:sldChg>
       <pc:sldChg chg="delSp modSp mod">
         <pc:chgData name="serra N" userId="9179cc10d8c62c08" providerId="LiveId" clId="{D30B40FB-DF3A-44D2-BDC3-B71D8C0FFE80}" dt="2026-08-17T06:39:58.845" v="6" actId="21"/>

</xml_diff>